<commit_message>
Se realizaron algunos retoques finales a el dashboard
</commit_message>
<xml_diff>
--- a/powerbi/background.pptx
+++ b/powerbi/background.pptx
@@ -263,7 +263,7 @@
           <a:p>
             <a:fld id="{CC556D51-F99A-4CAA-8BEE-C00A7210A191}" type="datetimeFigureOut">
               <a:rPr lang="es-AR" smtClean="0"/>
-              <a:t>15/3/2026</a:t>
+              <a:t>16/3/2026</a:t>
             </a:fld>
             <a:endParaRPr lang="es-AR"/>
           </a:p>
@@ -463,7 +463,7 @@
           <a:p>
             <a:fld id="{CC556D51-F99A-4CAA-8BEE-C00A7210A191}" type="datetimeFigureOut">
               <a:rPr lang="es-AR" smtClean="0"/>
-              <a:t>15/3/2026</a:t>
+              <a:t>16/3/2026</a:t>
             </a:fld>
             <a:endParaRPr lang="es-AR"/>
           </a:p>
@@ -673,7 +673,7 @@
           <a:p>
             <a:fld id="{CC556D51-F99A-4CAA-8BEE-C00A7210A191}" type="datetimeFigureOut">
               <a:rPr lang="es-AR" smtClean="0"/>
-              <a:t>15/3/2026</a:t>
+              <a:t>16/3/2026</a:t>
             </a:fld>
             <a:endParaRPr lang="es-AR"/>
           </a:p>
@@ -873,7 +873,7 @@
           <a:p>
             <a:fld id="{CC556D51-F99A-4CAA-8BEE-C00A7210A191}" type="datetimeFigureOut">
               <a:rPr lang="es-AR" smtClean="0"/>
-              <a:t>15/3/2026</a:t>
+              <a:t>16/3/2026</a:t>
             </a:fld>
             <a:endParaRPr lang="es-AR"/>
           </a:p>
@@ -1149,7 +1149,7 @@
           <a:p>
             <a:fld id="{CC556D51-F99A-4CAA-8BEE-C00A7210A191}" type="datetimeFigureOut">
               <a:rPr lang="es-AR" smtClean="0"/>
-              <a:t>15/3/2026</a:t>
+              <a:t>16/3/2026</a:t>
             </a:fld>
             <a:endParaRPr lang="es-AR"/>
           </a:p>
@@ -1417,7 +1417,7 @@
           <a:p>
             <a:fld id="{CC556D51-F99A-4CAA-8BEE-C00A7210A191}" type="datetimeFigureOut">
               <a:rPr lang="es-AR" smtClean="0"/>
-              <a:t>15/3/2026</a:t>
+              <a:t>16/3/2026</a:t>
             </a:fld>
             <a:endParaRPr lang="es-AR"/>
           </a:p>
@@ -1832,7 +1832,7 @@
           <a:p>
             <a:fld id="{CC556D51-F99A-4CAA-8BEE-C00A7210A191}" type="datetimeFigureOut">
               <a:rPr lang="es-AR" smtClean="0"/>
-              <a:t>15/3/2026</a:t>
+              <a:t>16/3/2026</a:t>
             </a:fld>
             <a:endParaRPr lang="es-AR"/>
           </a:p>
@@ -1974,7 +1974,7 @@
           <a:p>
             <a:fld id="{CC556D51-F99A-4CAA-8BEE-C00A7210A191}" type="datetimeFigureOut">
               <a:rPr lang="es-AR" smtClean="0"/>
-              <a:t>15/3/2026</a:t>
+              <a:t>16/3/2026</a:t>
             </a:fld>
             <a:endParaRPr lang="es-AR"/>
           </a:p>
@@ -2087,7 +2087,7 @@
           <a:p>
             <a:fld id="{CC556D51-F99A-4CAA-8BEE-C00A7210A191}" type="datetimeFigureOut">
               <a:rPr lang="es-AR" smtClean="0"/>
-              <a:t>15/3/2026</a:t>
+              <a:t>16/3/2026</a:t>
             </a:fld>
             <a:endParaRPr lang="es-AR"/>
           </a:p>
@@ -2400,7 +2400,7 @@
           <a:p>
             <a:fld id="{CC556D51-F99A-4CAA-8BEE-C00A7210A191}" type="datetimeFigureOut">
               <a:rPr lang="es-AR" smtClean="0"/>
-              <a:t>15/3/2026</a:t>
+              <a:t>16/3/2026</a:t>
             </a:fld>
             <a:endParaRPr lang="es-AR"/>
           </a:p>
@@ -2689,7 +2689,7 @@
           <a:p>
             <a:fld id="{CC556D51-F99A-4CAA-8BEE-C00A7210A191}" type="datetimeFigureOut">
               <a:rPr lang="es-AR" smtClean="0"/>
-              <a:t>15/3/2026</a:t>
+              <a:t>16/3/2026</a:t>
             </a:fld>
             <a:endParaRPr lang="es-AR"/>
           </a:p>
@@ -2932,7 +2932,7 @@
           <a:p>
             <a:fld id="{CC556D51-F99A-4CAA-8BEE-C00A7210A191}" type="datetimeFigureOut">
               <a:rPr lang="es-AR" smtClean="0"/>
-              <a:t>15/3/2026</a:t>
+              <a:t>16/3/2026</a:t>
             </a:fld>
             <a:endParaRPr lang="es-AR"/>
           </a:p>
@@ -3338,7 +3338,7 @@
     <p:bg>
       <p:bgPr>
         <a:solidFill>
-          <a:srgbClr val="8FB59D"/>
+          <a:srgbClr val="477A69"/>
         </a:solidFill>
         <a:effectLst/>
       </p:bgPr>
@@ -4066,6 +4066,14 @@
 <file path=ppt/slides/slide2.xml><?xml version="1.0" encoding="utf-8"?>
 <p:sld xmlns:a="http://schemas.openxmlformats.org/drawingml/2006/main" xmlns:r="http://schemas.openxmlformats.org/officeDocument/2006/relationships" xmlns:p="http://schemas.openxmlformats.org/presentationml/2006/main">
   <p:cSld>
+    <p:bg>
+      <p:bgPr>
+        <a:solidFill>
+          <a:srgbClr val="477A69"/>
+        </a:solidFill>
+        <a:effectLst/>
+      </p:bgPr>
+    </p:bg>
     <p:spTree>
       <p:nvGrpSpPr>
         <p:cNvPr id="1" name=""/>
@@ -4850,6 +4858,14 @@
 <file path=ppt/slides/slide3.xml><?xml version="1.0" encoding="utf-8"?>
 <p:sld xmlns:a="http://schemas.openxmlformats.org/drawingml/2006/main" xmlns:r="http://schemas.openxmlformats.org/officeDocument/2006/relationships" xmlns:p="http://schemas.openxmlformats.org/presentationml/2006/main">
   <p:cSld>
+    <p:bg>
+      <p:bgPr>
+        <a:solidFill>
+          <a:srgbClr val="477A69"/>
+        </a:solidFill>
+        <a:effectLst/>
+      </p:bgPr>
+    </p:bg>
     <p:spTree>
       <p:nvGrpSpPr>
         <p:cNvPr id="1" name=""/>

</xml_diff>